<commit_message>
docs: integrantes, prints dos três perfis e ajustes finais da entrega
- capa da apresentação com nomes e RMs; slide 5 com os prints de gestor e liderança
- PDF regerado a partir do PPTX
- README: Gradle JDK 17 (o 21 do Android Studio falha no jlink), integrantes e erro do Mongo 8.0
- plano: D5 e D8 concluídos
</commit_message>
<xml_diff>
--- a/docs/APRESENTACAO.pptx
+++ b/docs/APRESENTACAO.pptx
@@ -1956,24 +1956,24 @@
         </p:nvSpPr>
         <p:spPr>
           <a:xfrm>
-            <a:off x="822960" y="3931920"/>
-            <a:ext cx="10698480" cy="457200"/>
-          </a:xfrm>
-          <a:prstGeom prst="rect">
-            <a:avLst/>
-          </a:prstGeom>
-          <a:noFill/>
-          <a:ln/>
-        </p:spPr>
-        <p:txBody>
-          <a:bodyPr wrap="square" lIns="0" tIns="0" rIns="0" bIns="0" rtlCol="0" anchor="ctr"/>
+            <a:off x="822960" y="3840480"/>
+            <a:ext cx="10698480" cy="1280160"/>
+          </a:xfrm>
+          <a:prstGeom prst="rect">
+            <a:avLst/>
+          </a:prstGeom>
+          <a:noFill/>
+          <a:ln/>
+        </p:spPr>
+        <p:txBody>
+          <a:bodyPr wrap="square" lIns="0" tIns="0" rIns="0" bIns="0" rtlCol="0" anchor="t"/>
           <a:lstStyle/>
           <a:p>
             <a:pPr indent="0" marL="0">
               <a:buNone/>
             </a:pPr>
             <a:r>
-              <a:rPr lang="en-US" sz="1500" i="1" dirty="0">
+              <a:rPr lang="pt-BR" sz="1400" dirty="0">
                 <a:solidFill>
                   <a:srgbClr val="F9E795"/>
                 </a:solidFill>
@@ -1981,9 +1981,72 @@
                 <a:ea typeface="Calibri" pitchFamily="34" charset="-122"/>
                 <a:cs typeface="Calibri" pitchFamily="34" charset="-120"/>
               </a:rPr>
-              <a:t>[PREENCHER: nome completo e RM de cada integrante]</a:t>
-            </a:r>
-            <a:endParaRPr lang="en-US" sz="1500" dirty="0"/>
+              <a:t>Mateus Bhering Beltrão Santos · RM564760</a:t>
+            </a:r>
+          </a:p>
+          <a:p>
+            <a:pPr indent="0" marL="0">
+              <a:buNone/>
+            </a:pPr>
+            <a:r>
+              <a:rPr lang="pt-BR" sz="1400" dirty="0">
+                <a:solidFill>
+                  <a:srgbClr val="F9E795"/>
+                </a:solidFill>
+                <a:latin typeface="Calibri" pitchFamily="34" charset="0"/>
+                <a:ea typeface="Calibri" pitchFamily="34" charset="-122"/>
+                <a:cs typeface="Calibri" pitchFamily="34" charset="-120"/>
+              </a:rPr>
+              <a:t>Ariel Alves Amaral · RM564563</a:t>
+            </a:r>
+          </a:p>
+          <a:p>
+            <a:pPr indent="0" marL="0">
+              <a:buNone/>
+            </a:pPr>
+            <a:r>
+              <a:rPr lang="pt-BR" sz="1400" dirty="0">
+                <a:solidFill>
+                  <a:srgbClr val="F9E795"/>
+                </a:solidFill>
+                <a:latin typeface="Calibri" pitchFamily="34" charset="0"/>
+                <a:ea typeface="Calibri" pitchFamily="34" charset="-122"/>
+                <a:cs typeface="Calibri" pitchFamily="34" charset="-120"/>
+              </a:rPr>
+              <a:t>Wesley Santos de França · RM563666</a:t>
+            </a:r>
+          </a:p>
+          <a:p>
+            <a:pPr indent="0" marL="0">
+              <a:buNone/>
+            </a:pPr>
+            <a:r>
+              <a:rPr lang="pt-BR" sz="1400" dirty="0">
+                <a:solidFill>
+                  <a:srgbClr val="F9E795"/>
+                </a:solidFill>
+                <a:latin typeface="Calibri" pitchFamily="34" charset="0"/>
+                <a:ea typeface="Calibri" pitchFamily="34" charset="-122"/>
+                <a:cs typeface="Calibri" pitchFamily="34" charset="-120"/>
+              </a:rPr>
+              <a:t>Ronaldo dos Santos Silva · RM561414</a:t>
+            </a:r>
+          </a:p>
+          <a:p>
+            <a:pPr indent="0" marL="0">
+              <a:buNone/>
+            </a:pPr>
+            <a:r>
+              <a:rPr lang="pt-BR" sz="1400" dirty="0">
+                <a:solidFill>
+                  <a:srgbClr val="F9E795"/>
+                </a:solidFill>
+                <a:latin typeface="Calibri" pitchFamily="34" charset="0"/>
+                <a:ea typeface="Calibri" pitchFamily="34" charset="-122"/>
+                <a:cs typeface="Calibri" pitchFamily="34" charset="-120"/>
+              </a:rPr>
+              <a:t>Rodrigo Kumamoto Rêgo · RM566049</a:t>
+            </a:r>
           </a:p>
         </p:txBody>
       </p:sp>
@@ -6166,7 +6229,7 @@
       </p:sp>
       <p:pic>
         <p:nvPicPr>
-          <p:cNvPr id="4" name="Image 0" descr="/home/wesley/Documents/dev/FIAP/fiap_2-ano_fase-6-projeto-agua-branca/docs/prints/01_login.png">    </p:cNvPr>
+          <p:cNvPr id="4" name="Image 0" descr="Tela de login do app">    </p:cNvPr>
           <p:cNvPicPr>
             <a:picLocks noChangeAspect="1"/>
           </p:cNvPicPr>
@@ -6180,8 +6243,8 @@
         </p:blipFill>
         <p:spPr>
           <a:xfrm>
-            <a:off x="731520" y="1737360"/>
-            <a:ext cx="1920240" cy="3840480"/>
+            <a:off x="836087" y="1737360"/>
+            <a:ext cx="1711105" cy="3840480"/>
           </a:xfrm>
           <a:prstGeom prst="rect">
             <a:avLst/>
@@ -6229,7 +6292,7 @@
       </p:sp>
       <p:pic>
         <p:nvPicPr>
-          <p:cNvPr id="6" name="Image 1" descr="/home/wesley/Documents/dev/FIAP/fiap_2-ano_fase-6-projeto-agua-branca/docs/prints/02_operador_home.png">    </p:cNvPr>
+          <p:cNvPr id="6" name="Image 1" descr="Tela inicial do operador">    </p:cNvPr>
           <p:cNvPicPr>
             <a:picLocks noChangeAspect="1"/>
           </p:cNvPicPr>
@@ -6243,8 +6306,8 @@
         </p:blipFill>
         <p:spPr>
           <a:xfrm>
-            <a:off x="3657600" y="1737360"/>
-            <a:ext cx="1920240" cy="3840480"/>
+            <a:off x="3762167" y="1737360"/>
+            <a:ext cx="1711105" cy="3840480"/>
           </a:xfrm>
           <a:prstGeom prst="rect">
             <a:avLst/>
@@ -6290,59 +6353,56 @@
           </a:p>
         </p:txBody>
       </p:sp>
-      <p:sp>
-        <p:nvSpPr>
-          <p:cNvPr id="8" name="Shape 4"/>
-          <p:cNvSpPr/>
-          <p:nvPr/>
-        </p:nvSpPr>
-        <p:spPr>
-          <a:xfrm>
-            <a:off x="6583680" y="1737360"/>
-            <a:ext cx="1920240" cy="3840480"/>
-          </a:xfrm>
-          <a:prstGeom prst="roundRect">
-            <a:avLst>
-              <a:gd name="adj" fmla="val 4762"/>
-            </a:avLst>
-          </a:prstGeom>
-          <a:solidFill>
-            <a:srgbClr val="F2F3F7"/>
-          </a:solidFill>
-          <a:ln w="12700">
-            <a:solidFill>
-              <a:srgbClr val="C9CCDB"/>
-            </a:solidFill>
-            <a:prstDash val="dash"/>
-          </a:ln>
-        </p:spPr>
-      </p:sp>
-      <p:sp>
-        <p:nvSpPr>
-          <p:cNvPr id="9" name="Text 5"/>
-          <p:cNvSpPr txBox="1"/>
-          <p:nvPr/>
-        </p:nvSpPr>
-        <p:spPr>
-          <a:xfrm>
-            <a:off x="6583680" y="3291840"/>
-            <a:ext cx="1920240" cy="731520"/>
-          </a:xfrm>
-          <a:prstGeom prst="rect">
-            <a:avLst/>
-          </a:prstGeom>
-          <a:noFill/>
-          <a:ln/>
-        </p:spPr>
-        <p:txBody>
-          <a:bodyPr wrap="square" rtlCol="0" anchor="ctr"/>
+      <p:pic>
+        <p:nvPicPr>
+          <p:cNvPr id="8" name="Image 2" descr="Painel do gestor"/>
+          <p:cNvPicPr>
+            <a:picLocks noChangeAspect="1"/>
+          </p:cNvPicPr>
+          <p:nvPr/>
+        </p:nvPicPr>
+        <p:blipFill>
+          <a:blip r:embed="rId5"/>
+          <a:stretch>
+            <a:fillRect/>
+          </a:stretch>
+        </p:blipFill>
+        <p:spPr>
+          <a:xfrm>
+            <a:off x="6681130" y="1737360"/>
+            <a:ext cx="1725340" cy="3840480"/>
+          </a:xfrm>
+          <a:prstGeom prst="rect">
+            <a:avLst/>
+          </a:prstGeom>
+        </p:spPr>
+      </p:pic>
+      <p:sp>
+        <p:nvSpPr>
+          <p:cNvPr id="10" name="Text 6"/>
+          <p:cNvSpPr txBox="1"/>
+          <p:nvPr/>
+        </p:nvSpPr>
+        <p:spPr>
+          <a:xfrm>
+            <a:off x="6400800" y="5623560"/>
+            <a:ext cx="2286000" cy="457200"/>
+          </a:xfrm>
+          <a:prstGeom prst="rect">
+            <a:avLst/>
+          </a:prstGeom>
+          <a:noFill/>
+          <a:ln/>
+        </p:spPr>
+        <p:txBody>
+          <a:bodyPr wrap="square" lIns="0" tIns="0" rIns="0" bIns="0" rtlCol="0" anchor="ctr"/>
           <a:lstStyle/>
           <a:p>
             <a:pPr algn="ctr" indent="0" marL="0">
               <a:buNone/>
             </a:pPr>
             <a:r>
-              <a:rPr lang="en-US" sz="1200" b="1" dirty="0">
+              <a:rPr lang="en-US" sz="1100" dirty="0">
                 <a:solidFill>
                   <a:srgbClr val="5A6072"/>
                 </a:solidFill>
@@ -6350,151 +6410,36 @@
                 <a:ea typeface="Calibri" pitchFamily="34" charset="-122"/>
                 <a:cs typeface="Calibri" pitchFamily="34" charset="-120"/>
               </a:rPr>
-              <a:t>[INSERIR</a:t>
-            </a:r>
-            <a:endParaRPr lang="en-US" sz="1200" dirty="0"/>
-          </a:p>
-          <a:p>
-            <a:pPr algn="ctr" indent="0" marL="0">
-              <a:buNone/>
-            </a:pPr>
-            <a:r>
-              <a:rPr lang="en-US" sz="1200" b="1" dirty="0">
-                <a:solidFill>
-                  <a:srgbClr val="5A6072"/>
-                </a:solidFill>
-                <a:latin typeface="Calibri" pitchFamily="34" charset="0"/>
-                <a:ea typeface="Calibri" pitchFamily="34" charset="-122"/>
-                <a:cs typeface="Calibri" pitchFamily="34" charset="-120"/>
-              </a:rPr>
-              <a:t>PRINT]</a:t>
-            </a:r>
-            <a:endParaRPr lang="en-US" sz="1200" dirty="0"/>
-          </a:p>
-        </p:txBody>
-      </p:sp>
-      <p:sp>
-        <p:nvSpPr>
-          <p:cNvPr id="10" name="Text 6"/>
-          <p:cNvSpPr txBox="1"/>
-          <p:nvPr/>
-        </p:nvSpPr>
-        <p:spPr>
-          <a:xfrm>
-            <a:off x="6400800" y="5623560"/>
-            <a:ext cx="2286000" cy="457200"/>
-          </a:xfrm>
-          <a:prstGeom prst="rect">
-            <a:avLst/>
-          </a:prstGeom>
-          <a:noFill/>
-          <a:ln/>
-        </p:spPr>
-        <p:txBody>
-          <a:bodyPr wrap="square" lIns="0" tIns="0" rIns="0" bIns="0" rtlCol="0" anchor="ctr"/>
-          <a:lstStyle/>
-          <a:p>
-            <a:pPr algn="ctr" indent="0" marL="0">
-              <a:buNone/>
-            </a:pPr>
-            <a:r>
-              <a:rPr lang="en-US" sz="1100" dirty="0">
-                <a:solidFill>
-                  <a:srgbClr val="5A6072"/>
-                </a:solidFill>
-                <a:latin typeface="Calibri" pitchFamily="34" charset="0"/>
-                <a:ea typeface="Calibri" pitchFamily="34" charset="-122"/>
-                <a:cs typeface="Calibri" pitchFamily="34" charset="-120"/>
-              </a:rPr>
               <a:t>Gestor: painel e fila de ideias</a:t>
             </a:r>
             <a:endParaRPr lang="en-US" sz="1100" dirty="0"/>
           </a:p>
         </p:txBody>
       </p:sp>
-      <p:sp>
-        <p:nvSpPr>
-          <p:cNvPr id="11" name="Shape 7"/>
-          <p:cNvSpPr/>
-          <p:nvPr/>
-        </p:nvSpPr>
-        <p:spPr>
-          <a:xfrm>
-            <a:off x="9509760" y="1737360"/>
-            <a:ext cx="1920240" cy="3840480"/>
-          </a:xfrm>
-          <a:prstGeom prst="roundRect">
-            <a:avLst>
-              <a:gd name="adj" fmla="val 4762"/>
-            </a:avLst>
-          </a:prstGeom>
-          <a:solidFill>
-            <a:srgbClr val="F2F3F7"/>
-          </a:solidFill>
-          <a:ln w="12700">
-            <a:solidFill>
-              <a:srgbClr val="C9CCDB"/>
-            </a:solidFill>
-            <a:prstDash val="dash"/>
-          </a:ln>
-        </p:spPr>
-      </p:sp>
-      <p:sp>
-        <p:nvSpPr>
-          <p:cNvPr id="12" name="Text 8"/>
-          <p:cNvSpPr txBox="1"/>
-          <p:nvPr/>
-        </p:nvSpPr>
-        <p:spPr>
-          <a:xfrm>
-            <a:off x="9509760" y="3291840"/>
-            <a:ext cx="1920240" cy="731520"/>
-          </a:xfrm>
-          <a:prstGeom prst="rect">
-            <a:avLst/>
-          </a:prstGeom>
-          <a:noFill/>
-          <a:ln/>
-        </p:spPr>
-        <p:txBody>
-          <a:bodyPr wrap="square" rtlCol="0" anchor="ctr"/>
-          <a:lstStyle/>
-          <a:p>
-            <a:pPr algn="ctr" indent="0" marL="0">
-              <a:buNone/>
-            </a:pPr>
-            <a:r>
-              <a:rPr lang="en-US" sz="1200" b="1" dirty="0">
-                <a:solidFill>
-                  <a:srgbClr val="5A6072"/>
-                </a:solidFill>
-                <a:latin typeface="Calibri" pitchFamily="34" charset="0"/>
-                <a:ea typeface="Calibri" pitchFamily="34" charset="-122"/>
-                <a:cs typeface="Calibri" pitchFamily="34" charset="-120"/>
-              </a:rPr>
-              <a:t>[INSERIR</a:t>
-            </a:r>
-            <a:endParaRPr lang="en-US" sz="1200" dirty="0"/>
-          </a:p>
-          <a:p>
-            <a:pPr algn="ctr" indent="0" marL="0">
-              <a:buNone/>
-            </a:pPr>
-            <a:r>
-              <a:rPr lang="en-US" sz="1200" b="1" dirty="0">
-                <a:solidFill>
-                  <a:srgbClr val="5A6072"/>
-                </a:solidFill>
-                <a:latin typeface="Calibri" pitchFamily="34" charset="0"/>
-                <a:ea typeface="Calibri" pitchFamily="34" charset="-122"/>
-                <a:cs typeface="Calibri" pitchFamily="34" charset="-120"/>
-              </a:rPr>
-              <a:t>PRINT]</a:t>
-            </a:r>
-            <a:endParaRPr lang="en-US" sz="1200" dirty="0"/>
-          </a:p>
-        </p:txBody>
-      </p:sp>
+      <p:pic>
+        <p:nvPicPr>
+          <p:cNvPr id="11" name="Image 3" descr="Dashboard da liderança"/>
+          <p:cNvPicPr>
+            <a:picLocks noChangeAspect="1"/>
+          </p:cNvPicPr>
+          <p:nvPr/>
+        </p:nvPicPr>
+        <p:blipFill>
+          <a:blip r:embed="rId6"/>
+          <a:stretch>
+            <a:fillRect/>
+          </a:stretch>
+        </p:blipFill>
+        <p:spPr>
+          <a:xfrm>
+            <a:off x="9607210" y="1737360"/>
+            <a:ext cx="1725340" cy="3840480"/>
+          </a:xfrm>
+          <a:prstGeom prst="rect">
+            <a:avLst/>
+          </a:prstGeom>
+        </p:spPr>
+      </p:pic>
       <p:sp>
         <p:nvSpPr>
           <p:cNvPr id="13" name="Text 9"/>

</xml_diff>